<commit_message>
docs: deck regenerado com o slide da jornada (28 slides)
Generated by Fabio Franceschetto helped by [Claude Code](https://claude.com/claude-code)
</commit_message>
<xml_diff>
--- a/reports/containerizacao-palestra.pptx
+++ b/reports/containerizacao-palestra.pptx
@@ -32,6 +32,7 @@
     <p:sldId id="280" r:id="rId32"/>
     <p:sldId id="281" r:id="rId33"/>
     <p:sldId id="282" r:id="rId34"/>
+    <p:sldId id="283" r:id="rId35"/>
   </p:sldIdLst>
   <p:sldSz cx="12191695" cy="6858000" type="screen4x3"/>
   <p:notesSz cx="6858000" cy="9144000"/>
@@ -442,6 +443,400 @@
 </c:chartSpace>
 </file>
 
+<file path=ppt/charts/chart2.xml><?xml version="1.0" encoding="utf-8"?>
+<c:chartSpace xmlns:c="http://schemas.openxmlformats.org/drawingml/2006/chart" xmlns:a="http://schemas.openxmlformats.org/drawingml/2006/main" xmlns:r="http://schemas.openxmlformats.org/officeDocument/2006/relationships">
+  <c:date1904 val="0"/>
+  <c:chart>
+    <c:autoTitleDeleted val="1"/>
+    <c:plotArea>
+      <c:barChart>
+        <c:barDir val="col"/>
+        <c:grouping val="clustered"/>
+        <c:ser>
+          <c:idx val="0"/>
+          <c:order val="0"/>
+          <c:tx>
+            <c:strRef>
+              <c:f>Sheet1!$B$1</c:f>
+              <c:strCache>
+                <c:ptCount val="1"/>
+                <c:pt idx="0">
+                  <c:v>valor</c:v>
+                </c:pt>
+              </c:strCache>
+            </c:strRef>
+          </c:tx>
+          <c:dPt>
+            <c:idx val="0"/>
+            <c:spPr>
+              <a:solidFill>
+                <a:srgbClr val="2496ED"/>
+              </a:solidFill>
+            </c:spPr>
+          </c:dPt>
+          <c:dPt>
+            <c:idx val="1"/>
+            <c:spPr>
+              <a:solidFill>
+                <a:srgbClr val="2496ED"/>
+              </a:solidFill>
+            </c:spPr>
+          </c:dPt>
+          <c:dPt>
+            <c:idx val="2"/>
+            <c:spPr>
+              <a:solidFill>
+                <a:srgbClr val="2496ED"/>
+              </a:solidFill>
+            </c:spPr>
+          </c:dPt>
+          <c:dPt>
+            <c:idx val="3"/>
+            <c:spPr>
+              <a:solidFill>
+                <a:srgbClr val="1FC8B4"/>
+              </a:solidFill>
+            </c:spPr>
+          </c:dPt>
+          <c:cat>
+            <c:strRef>
+              <c:f>Sheet1!$A$2:$A$5</c:f>
+              <c:strCache>
+                <c:ptCount val="4"/>
+                <c:pt idx="0">
+                  <c:v>1. single-stage</c:v>
+                </c:pt>
+                <c:pt idx="1">
+                  <c:v>2. multi-stage</c:v>
+                </c:pt>
+                <c:pt idx="2">
+                  <c:v>3. distroless</c:v>
+                </c:pt>
+                <c:pt idx="3">
+                  <c:v>4. Go + scratch</c:v>
+                </c:pt>
+              </c:strCache>
+            </c:strRef>
+          </c:cat>
+          <c:val>
+            <c:numRef>
+              <c:f>Sheet1!$B$2:$B$5</c:f>
+              <c:numCache>
+                <c:formatCode>General</c:formatCode>
+                <c:ptCount val="4"/>
+                <c:pt idx="0">
+                  <c:v>2070</c:v>
+                </c:pt>
+                <c:pt idx="1">
+                  <c:v>394</c:v>
+                </c:pt>
+                <c:pt idx="2">
+                  <c:v>361</c:v>
+                </c:pt>
+                <c:pt idx="3">
+                  <c:v>9</c:v>
+                </c:pt>
+              </c:numCache>
+            </c:numRef>
+          </c:val>
+        </c:ser>
+        <c:dLbls>
+          <c:numFmt formatCode="#,##0" sourceLinked="0"/>
+          <c:txPr>
+            <a:bodyPr/>
+            <a:lstStyle/>
+            <a:p>
+              <a:pPr>
+                <a:defRPr sz="1500" b="1">
+                  <a:solidFill>
+                    <a:srgbClr val="FFFFFF"/>
+                  </a:solidFill>
+                </a:defRPr>
+              </a:pPr>
+            </a:p>
+          </c:txPr>
+          <c:dLblPos val="outEnd"/>
+          <c:showLegendKey val="0"/>
+          <c:showVal val="1"/>
+          <c:showCatName val="0"/>
+          <c:showSerName val="0"/>
+          <c:showPercent val="0"/>
+          <c:showBubbleSize val="0"/>
+          <c:showLeaderLines val="1"/>
+        </c:dLbls>
+        <c:gapWidth val="60"/>
+        <c:axId val="-2068027336"/>
+        <c:axId val="-2113994440"/>
+      </c:barChart>
+      <c:catAx>
+        <c:axId val="-2068027336"/>
+        <c:scaling>
+          <c:orientation val="minMax"/>
+        </c:scaling>
+        <c:delete val="0"/>
+        <c:axPos val="b"/>
+        <c:majorTickMark val="out"/>
+        <c:minorTickMark val="none"/>
+        <c:tickLblPos val="nextTo"/>
+        <c:spPr>
+          <a:ln>
+            <a:solidFill>
+              <a:srgbClr val="13314A"/>
+            </a:solidFill>
+          </a:ln>
+        </c:spPr>
+        <c:txPr>
+          <a:bodyPr/>
+          <a:lstStyle/>
+          <a:p>
+            <a:pPr>
+              <a:defRPr sz="1300">
+                <a:solidFill>
+                  <a:srgbClr val="FFFFFF"/>
+                </a:solidFill>
+              </a:defRPr>
+            </a:pPr>
+          </a:p>
+        </c:txPr>
+        <c:crossAx val="-2113994440"/>
+        <c:crosses val="autoZero"/>
+        <c:auto val="1"/>
+        <c:lblAlgn val="ctr"/>
+        <c:lblOffset val="100"/>
+        <c:noMultiLvlLbl val="0"/>
+      </c:catAx>
+      <c:valAx>
+        <c:axId val="-2113994440"/>
+        <c:scaling/>
+        <c:delete/>
+        <c:axPos val="l"/>
+        <c:majorTickMark val="out"/>
+        <c:minorTickMark val="none"/>
+        <c:tickLblPos val="nextTo"/>
+        <c:crossAx val="-2068027336"/>
+        <c:crosses val="autoZero"/>
+      </c:valAx>
+    </c:plotArea>
+    <c:dispBlanksAs val="gap"/>
+  </c:chart>
+  <c:txPr>
+    <a:bodyPr/>
+    <a:lstStyle/>
+    <a:p>
+      <a:pPr>
+        <a:defRPr sz="1300">
+          <a:solidFill>
+            <a:srgbClr val="A9BCD0"/>
+          </a:solidFill>
+          <a:latin typeface="Calibri"/>
+        </a:defRPr>
+      </a:pPr>
+      <a:endParaRPr lang="en-US"/>
+    </a:p>
+  </c:txPr>
+  <c:externalData r:id="rId1">
+    <c:autoUpdate val="0"/>
+  </c:externalData>
+</c:chartSpace>
+</file>
+
+<file path=ppt/charts/chart3.xml><?xml version="1.0" encoding="utf-8"?>
+<c:chartSpace xmlns:c="http://schemas.openxmlformats.org/drawingml/2006/chart" xmlns:a="http://schemas.openxmlformats.org/drawingml/2006/main" xmlns:r="http://schemas.openxmlformats.org/officeDocument/2006/relationships">
+  <c:date1904 val="0"/>
+  <c:chart>
+    <c:autoTitleDeleted val="1"/>
+    <c:plotArea>
+      <c:barChart>
+        <c:barDir val="col"/>
+        <c:grouping val="clustered"/>
+        <c:ser>
+          <c:idx val="0"/>
+          <c:order val="0"/>
+          <c:tx>
+            <c:strRef>
+              <c:f>Sheet1!$B$1</c:f>
+              <c:strCache>
+                <c:ptCount val="1"/>
+                <c:pt idx="0">
+                  <c:v>valor</c:v>
+                </c:pt>
+              </c:strCache>
+            </c:strRef>
+          </c:tx>
+          <c:dPt>
+            <c:idx val="0"/>
+            <c:spPr>
+              <a:solidFill>
+                <a:srgbClr val="2496ED"/>
+              </a:solidFill>
+            </c:spPr>
+          </c:dPt>
+          <c:dPt>
+            <c:idx val="1"/>
+            <c:spPr>
+              <a:solidFill>
+                <a:srgbClr val="2496ED"/>
+              </a:solidFill>
+            </c:spPr>
+          </c:dPt>
+          <c:dPt>
+            <c:idx val="2"/>
+            <c:spPr>
+              <a:solidFill>
+                <a:srgbClr val="2496ED"/>
+              </a:solidFill>
+            </c:spPr>
+          </c:dPt>
+          <c:dPt>
+            <c:idx val="3"/>
+            <c:spPr>
+              <a:solidFill>
+                <a:srgbClr val="1FC8B4"/>
+              </a:solidFill>
+            </c:spPr>
+          </c:dPt>
+          <c:cat>
+            <c:strRef>
+              <c:f>Sheet1!$A$2:$A$5</c:f>
+              <c:strCache>
+                <c:ptCount val="4"/>
+                <c:pt idx="0">
+                  <c:v>1. single-stage</c:v>
+                </c:pt>
+                <c:pt idx="1">
+                  <c:v>2. multi-stage</c:v>
+                </c:pt>
+                <c:pt idx="2">
+                  <c:v>3. distroless</c:v>
+                </c:pt>
+                <c:pt idx="3">
+                  <c:v>4. Go + scratch</c:v>
+                </c:pt>
+              </c:strCache>
+            </c:strRef>
+          </c:cat>
+          <c:val>
+            <c:numRef>
+              <c:f>Sheet1!$B$2:$B$5</c:f>
+              <c:numCache>
+                <c:formatCode>General</c:formatCode>
+                <c:ptCount val="4"/>
+                <c:pt idx="0">
+                  <c:v>562</c:v>
+                </c:pt>
+                <c:pt idx="1">
+                  <c:v>36</c:v>
+                </c:pt>
+                <c:pt idx="2">
+                  <c:v>33</c:v>
+                </c:pt>
+                <c:pt idx="3">
+                  <c:v>0</c:v>
+                </c:pt>
+              </c:numCache>
+            </c:numRef>
+          </c:val>
+        </c:ser>
+        <c:dLbls>
+          <c:numFmt formatCode="#,##0" sourceLinked="0"/>
+          <c:txPr>
+            <a:bodyPr/>
+            <a:lstStyle/>
+            <a:p>
+              <a:pPr>
+                <a:defRPr sz="1500" b="1">
+                  <a:solidFill>
+                    <a:srgbClr val="FFFFFF"/>
+                  </a:solidFill>
+                </a:defRPr>
+              </a:pPr>
+            </a:p>
+          </c:txPr>
+          <c:dLblPos val="outEnd"/>
+          <c:showLegendKey val="0"/>
+          <c:showVal val="1"/>
+          <c:showCatName val="0"/>
+          <c:showSerName val="0"/>
+          <c:showPercent val="0"/>
+          <c:showBubbleSize val="0"/>
+          <c:showLeaderLines val="1"/>
+        </c:dLbls>
+        <c:gapWidth val="60"/>
+        <c:axId val="-2068027336"/>
+        <c:axId val="-2113994440"/>
+      </c:barChart>
+      <c:catAx>
+        <c:axId val="-2068027336"/>
+        <c:scaling>
+          <c:orientation val="minMax"/>
+        </c:scaling>
+        <c:delete val="0"/>
+        <c:axPos val="b"/>
+        <c:majorTickMark val="out"/>
+        <c:minorTickMark val="none"/>
+        <c:tickLblPos val="nextTo"/>
+        <c:spPr>
+          <a:ln>
+            <a:solidFill>
+              <a:srgbClr val="13314A"/>
+            </a:solidFill>
+          </a:ln>
+        </c:spPr>
+        <c:txPr>
+          <a:bodyPr/>
+          <a:lstStyle/>
+          <a:p>
+            <a:pPr>
+              <a:defRPr sz="1300">
+                <a:solidFill>
+                  <a:srgbClr val="FFFFFF"/>
+                </a:solidFill>
+              </a:defRPr>
+            </a:pPr>
+          </a:p>
+        </c:txPr>
+        <c:crossAx val="-2113994440"/>
+        <c:crosses val="autoZero"/>
+        <c:auto val="1"/>
+        <c:lblAlgn val="ctr"/>
+        <c:lblOffset val="100"/>
+        <c:noMultiLvlLbl val="0"/>
+      </c:catAx>
+      <c:valAx>
+        <c:axId val="-2113994440"/>
+        <c:scaling/>
+        <c:delete/>
+        <c:axPos val="l"/>
+        <c:majorTickMark val="out"/>
+        <c:minorTickMark val="none"/>
+        <c:tickLblPos val="nextTo"/>
+        <c:crossAx val="-2068027336"/>
+        <c:crosses val="autoZero"/>
+      </c:valAx>
+    </c:plotArea>
+    <c:dispBlanksAs val="gap"/>
+  </c:chart>
+  <c:txPr>
+    <a:bodyPr/>
+    <a:lstStyle/>
+    <a:p>
+      <a:pPr>
+        <a:defRPr sz="1300">
+          <a:solidFill>
+            <a:srgbClr val="A9BCD0"/>
+          </a:solidFill>
+          <a:latin typeface="Calibri"/>
+        </a:defRPr>
+      </a:pPr>
+      <a:endParaRPr lang="en-US"/>
+    </a:p>
+  </c:txPr>
+  <c:externalData r:id="rId1">
+    <c:autoUpdate val="0"/>
+  </c:externalData>
+</c:chartSpace>
+</file>
+
 <file path=ppt/notesMasters/notesMaster1.xml><?xml version="1.0" encoding="utf-8"?>
 <p:notesMaster xmlns:a="http://schemas.openxmlformats.org/drawingml/2006/main" xmlns:p="http://schemas.openxmlformats.org/presentationml/2006/main" xmlns:r="http://schemas.openxmlformats.org/officeDocument/2006/relationships">
   <p:cSld>
@@ -2097,7 +2492,7 @@
           <a:lstStyle/>
           <a:p>
             <a:r>
-              <a:t>Recapitular o placar: de backend:single (2.070 MB, root, 25 CRITICAL e 537 HIGH) a api-go:scratch (9 MB, não-root, 0 CVEs). Próximos passos e link para a palestra AppSec.</a:t>
+              <a:t>O resumo da aula num slide: cada técnica é um degrau. Multi-stage com alpine já corta 81% do tamanho e 94% das CVEs críticas e altas; distroless tira o shell; e o binário estático em scratch chega a 9 MB e zero CVEs. Volte à votação: o que mais pesou não foi a base, foi o multi-stage e o que vai dentro da imagem.</a:t>
             </a:r>
           </a:p>
         </p:txBody>
@@ -2123,6 +2518,76 @@
 </file>
 
 <file path=ppt/notesSlides/notesSlide27.xml><?xml version="1.0" encoding="utf-8"?>
+<p:notes xmlns:a="http://schemas.openxmlformats.org/drawingml/2006/main" xmlns:p="http://schemas.openxmlformats.org/presentationml/2006/main" xmlns:r="http://schemas.openxmlformats.org/officeDocument/2006/relationships">
+  <p:cSld>
+    <p:spTree>
+      <p:nvGrpSpPr>
+        <p:cNvPr id="1" name=""/>
+        <p:cNvGrpSpPr/>
+        <p:nvPr/>
+      </p:nvGrpSpPr>
+      <p:grpSpPr>
+        <a:xfrm>
+          <a:off x="0" y="0"/>
+          <a:ext cx="0" cy="0"/>
+          <a:chOff x="0" y="0"/>
+          <a:chExt cx="0" cy="0"/>
+        </a:xfrm>
+      </p:grpSpPr>
+      <p:sp>
+        <p:nvSpPr>
+          <p:cNvPr id="2" name="Slide Image Placeholder 1"/>
+          <p:cNvSpPr>
+            <a:spLocks noGrp="1"/>
+          </p:cNvSpPr>
+          <p:nvPr>
+            <p:ph type="sldImg" idx="2"/>
+          </p:nvPr>
+        </p:nvSpPr>
+        <p:spPr/>
+      </p:sp>
+      <p:sp>
+        <p:nvSpPr>
+          <p:cNvPr id="3" name="Notes Placeholder 2"/>
+          <p:cNvSpPr>
+            <a:spLocks noGrp="1"/>
+          </p:cNvSpPr>
+          <p:nvPr>
+            <p:ph type="body" idx="3" sz="quarter"/>
+          </p:nvPr>
+        </p:nvSpPr>
+        <p:spPr/>
+        <p:txBody>
+          <a:bodyPr/>
+          <a:lstStyle/>
+          <a:p>
+            <a:r>
+              <a:t>Recapitular o placar: de backend:single (2.070 MB, root, 25 CRITICAL e 537 HIGH) a api-go:scratch (9 MB, não-root, 0 CVEs). Próximos passos e link para a palestra AppSec.</a:t>
+            </a:r>
+          </a:p>
+        </p:txBody>
+      </p:sp>
+      <p:sp>
+        <p:nvSpPr>
+          <p:cNvPr id="4" name="Slide Number Placeholder 3"/>
+          <p:cNvSpPr>
+            <a:spLocks noGrp="1"/>
+          </p:cNvSpPr>
+          <p:nvPr>
+            <p:ph type="sldNum" idx="5" sz="quarter"/>
+          </p:nvPr>
+        </p:nvSpPr>
+        <p:spPr/>
+      </p:sp>
+    </p:spTree>
+  </p:cSld>
+  <p:clrMapOvr>
+    <a:masterClrMapping/>
+  </p:clrMapOvr>
+</p:notes>
+</file>
+
+<file path=ppt/notesSlides/notesSlide28.xml><?xml version="1.0" encoding="utf-8"?>
 <p:notes xmlns:a="http://schemas.openxmlformats.org/drawingml/2006/main" xmlns:p="http://schemas.openxmlformats.org/presentationml/2006/main" xmlns:r="http://schemas.openxmlformats.org/officeDocument/2006/relationships">
   <p:cSld>
     <p:spTree>
@@ -21593,7 +22058,7 @@
                 </a:solidFill>
                 <a:latin typeface="Calibri"/>
               </a:rPr>
-              <a:t>ENCERRAMENTO</a:t>
+              <a:t>ENCERRAMENTO · A JORNADA</a:t>
             </a:r>
           </a:p>
         </p:txBody>
@@ -21632,7 +22097,7 @@
                 </a:solidFill>
                 <a:latin typeface="Calibri"/>
               </a:rPr>
-              <a:t>Para levar para segunda-feira</a:t>
+              <a:t>Quanto cada técnica enxuga</a:t>
             </a:r>
           </a:p>
         </p:txBody>
@@ -21645,8 +22110,8 @@
         </p:nvSpPr>
         <p:spPr>
           <a:xfrm>
-            <a:off x="548640" y="1645920"/>
-            <a:ext cx="3520440" cy="2194560"/>
+            <a:off x="548640" y="1508760"/>
+            <a:ext cx="5349240" cy="4526280"/>
           </a:xfrm>
           <a:prstGeom prst="roundRect">
             <a:avLst>
@@ -21685,106 +22150,14 @@
       </p:sp>
       <p:sp>
         <p:nvSpPr>
-          <p:cNvPr id="5" name="Oval 4"/>
-          <p:cNvSpPr/>
-          <p:nvPr/>
-        </p:nvSpPr>
-        <p:spPr>
-          <a:xfrm>
-            <a:off x="777240" y="1847088"/>
-            <a:ext cx="411480" cy="411480"/>
-          </a:xfrm>
-          <a:prstGeom prst="ellipse">
-            <a:avLst/>
-          </a:prstGeom>
-          <a:solidFill>
-            <a:srgbClr val="2496ED"/>
-          </a:solidFill>
-          <a:ln>
-            <a:noFill/>
-          </a:ln>
-          <a:effectLst/>
-        </p:spPr>
-        <p:style>
-          <a:lnRef idx="1">
-            <a:schemeClr val="accent1"/>
-          </a:lnRef>
-          <a:fillRef idx="3">
-            <a:schemeClr val="accent1"/>
-          </a:fillRef>
-          <a:effectRef idx="2">
-            <a:schemeClr val="accent1"/>
-          </a:effectRef>
-          <a:fontRef idx="minor">
-            <a:schemeClr val="lt1"/>
-          </a:fontRef>
-        </p:style>
-        <p:txBody>
-          <a:bodyPr rtlCol="0" anchor="ctr" lIns="0" rIns="0" tIns="0" bIns="0"/>
-          <a:lstStyle/>
-          <a:p>
-            <a:pPr algn="ctr"/>
-            <a:r>
-              <a:rPr sz="1400" b="1">
-                <a:solidFill>
-                  <a:srgbClr val="0B1E2D"/>
-                </a:solidFill>
-                <a:latin typeface="Calibri"/>
-              </a:rPr>
-              <a:t>1</a:t>
-            </a:r>
-          </a:p>
-        </p:txBody>
-      </p:sp>
-      <p:sp>
-        <p:nvSpPr>
-          <p:cNvPr id="6" name="TextBox 5"/>
+          <p:cNvPr id="5" name="TextBox 4"/>
           <p:cNvSpPr txBox="1"/>
           <p:nvPr/>
         </p:nvSpPr>
         <p:spPr>
           <a:xfrm>
-            <a:off x="1325880" y="1847088"/>
-            <a:ext cx="2560320" cy="411480"/>
-          </a:xfrm>
-          <a:prstGeom prst="rect">
-            <a:avLst/>
-          </a:prstGeom>
-          <a:noFill/>
-        </p:spPr>
-        <p:txBody>
-          <a:bodyPr wrap="square" anchor="ctr" lIns="0" rIns="0" tIns="0" bIns="0">
-            <a:spAutoFit/>
-          </a:bodyPr>
-          <a:lstStyle/>
-          <a:p>
-            <a:pPr algn="l">
-              <a:spcAft>
-                <a:spcPts val="400"/>
-              </a:spcAft>
-            </a:pPr>
-            <a:r>
-              <a:rPr sz="1800" b="1" i="0">
-                <a:solidFill>
-                  <a:srgbClr val="FFFFFF"/>
-                </a:solidFill>
-                <a:latin typeface="Calibri"/>
-              </a:rPr>
-              <a:t>Aplicar o checklist</a:t>
-            </a:r>
-          </a:p>
-        </p:txBody>
-      </p:sp>
-      <p:sp>
-        <p:nvSpPr>
-          <p:cNvPr id="7" name="TextBox 6"/>
-          <p:cNvSpPr txBox="1"/>
-          <p:nvPr/>
-        </p:nvSpPr>
-        <p:spPr>
-          <a:xfrm>
-            <a:off x="777240" y="2377440"/>
-            <a:ext cx="3063240" cy="1325880"/>
+            <a:off x="822959" y="1645920"/>
+            <a:ext cx="3108960" cy="411480"/>
           </a:xfrm>
           <a:prstGeom prst="rect">
             <a:avLst/>
@@ -21799,37 +22172,78 @@
           <a:p>
             <a:pPr algn="l">
               <a:spcAft>
-                <a:spcPts val="500"/>
-              </a:spcAft>
-            </a:pPr>
-            <a:r>
-              <a:rPr sz="1600" b="0" i="0">
-                <a:solidFill>
-                  <a:srgbClr val="A9BCD0"/>
-                </a:solidFill>
-                <a:latin typeface="Calibri"/>
-              </a:rPr>
-              <a:t>nos Dockerfiles do time</a:t>
-            </a:r>
-          </a:p>
-          <a:p>
-            <a:pPr algn="l">
-              <a:spcAft>
-                <a:spcPts val="500"/>
-              </a:spcAft>
-            </a:pPr>
-            <a:r>
-              <a:rPr sz="1600" b="0" i="0">
-                <a:solidFill>
-                  <a:srgbClr val="A9BCD0"/>
-                </a:solidFill>
-                <a:latin typeface="Calibri"/>
-              </a:rPr>
-              <a:t>comece pelo multi-stage</a:t>
-            </a:r>
-          </a:p>
-        </p:txBody>
-      </p:sp>
+                <a:spcPts val="400"/>
+              </a:spcAft>
+            </a:pPr>
+            <a:r>
+              <a:rPr sz="1700" b="1" i="0">
+                <a:solidFill>
+                  <a:srgbClr val="FFFFFF"/>
+                </a:solidFill>
+                <a:latin typeface="Calibri"/>
+              </a:rPr>
+              <a:t>Tamanho da imagem (MB)</a:t>
+            </a:r>
+          </a:p>
+        </p:txBody>
+      </p:sp>
+      <p:sp>
+        <p:nvSpPr>
+          <p:cNvPr id="6" name="TextBox 5"/>
+          <p:cNvSpPr txBox="1"/>
+          <p:nvPr/>
+        </p:nvSpPr>
+        <p:spPr>
+          <a:xfrm>
+            <a:off x="3291840" y="1572768"/>
+            <a:ext cx="2377440" cy="548640"/>
+          </a:xfrm>
+          <a:prstGeom prst="rect">
+            <a:avLst/>
+          </a:prstGeom>
+          <a:noFill/>
+        </p:spPr>
+        <p:txBody>
+          <a:bodyPr wrap="square" anchor="t" lIns="0" rIns="0" tIns="0" bIns="0">
+            <a:spAutoFit/>
+          </a:bodyPr>
+          <a:lstStyle/>
+          <a:p>
+            <a:pPr algn="r">
+              <a:spcAft>
+                <a:spcPts val="400"/>
+              </a:spcAft>
+            </a:pPr>
+            <a:r>
+              <a:rPr sz="2600" b="1" i="0">
+                <a:solidFill>
+                  <a:srgbClr val="1FC8B4"/>
+                </a:solidFill>
+                <a:latin typeface="Calibri"/>
+              </a:rPr>
+              <a:t>−99,6%</a:t>
+            </a:r>
+          </a:p>
+        </p:txBody>
+      </p:sp>
+      <p:graphicFrame>
+        <p:nvGraphicFramePr>
+          <p:cNvPr id="7" name="Chart 6"/>
+          <p:cNvGraphicFramePr>
+            <a:graphicFrameLocks noGrp="1"/>
+          </p:cNvGraphicFramePr>
+          <p:nvPr/>
+        </p:nvGraphicFramePr>
+        <p:xfrm>
+          <a:off x="685800" y="2240280"/>
+          <a:ext cx="5074920" cy="3703320"/>
+        </p:xfrm>
+        <a:graphic>
+          <a:graphicData uri="http://schemas.openxmlformats.org/drawingml/2006/chart">
+            <c:chart xmlns:c="http://schemas.openxmlformats.org/drawingml/2006/chart" r:id="rId3"/>
+          </a:graphicData>
+        </a:graphic>
+      </p:graphicFrame>
       <p:sp>
         <p:nvSpPr>
           <p:cNvPr id="8" name="Rounded Rectangle 7"/>
@@ -21838,8 +22252,8 @@
         </p:nvSpPr>
         <p:spPr>
           <a:xfrm>
-            <a:off x="4297679" y="1645920"/>
-            <a:ext cx="3520440" cy="2194560"/>
+            <a:off x="6263640" y="1508760"/>
+            <a:ext cx="5349240" cy="4526280"/>
           </a:xfrm>
           <a:prstGeom prst="roundRect">
             <a:avLst>
@@ -21878,106 +22292,14 @@
       </p:sp>
       <p:sp>
         <p:nvSpPr>
-          <p:cNvPr id="9" name="Oval 8"/>
-          <p:cNvSpPr/>
-          <p:nvPr/>
-        </p:nvSpPr>
-        <p:spPr>
-          <a:xfrm>
-            <a:off x="4526279" y="1847088"/>
-            <a:ext cx="411480" cy="411480"/>
-          </a:xfrm>
-          <a:prstGeom prst="ellipse">
-            <a:avLst/>
-          </a:prstGeom>
-          <a:solidFill>
-            <a:srgbClr val="FFB020"/>
-          </a:solidFill>
-          <a:ln>
-            <a:noFill/>
-          </a:ln>
-          <a:effectLst/>
-        </p:spPr>
-        <p:style>
-          <a:lnRef idx="1">
-            <a:schemeClr val="accent1"/>
-          </a:lnRef>
-          <a:fillRef idx="3">
-            <a:schemeClr val="accent1"/>
-          </a:fillRef>
-          <a:effectRef idx="2">
-            <a:schemeClr val="accent1"/>
-          </a:effectRef>
-          <a:fontRef idx="minor">
-            <a:schemeClr val="lt1"/>
-          </a:fontRef>
-        </p:style>
-        <p:txBody>
-          <a:bodyPr rtlCol="0" anchor="ctr" lIns="0" rIns="0" tIns="0" bIns="0"/>
-          <a:lstStyle/>
-          <a:p>
-            <a:pPr algn="ctr"/>
-            <a:r>
-              <a:rPr sz="1400" b="1">
-                <a:solidFill>
-                  <a:srgbClr val="0B1E2D"/>
-                </a:solidFill>
-                <a:latin typeface="Calibri"/>
-              </a:rPr>
-              <a:t>2</a:t>
-            </a:r>
-          </a:p>
-        </p:txBody>
-      </p:sp>
-      <p:sp>
-        <p:nvSpPr>
-          <p:cNvPr id="10" name="TextBox 9"/>
+          <p:cNvPr id="9" name="TextBox 8"/>
           <p:cNvSpPr txBox="1"/>
           <p:nvPr/>
         </p:nvSpPr>
         <p:spPr>
           <a:xfrm>
-            <a:off x="5074919" y="1847088"/>
-            <a:ext cx="2560320" cy="411480"/>
-          </a:xfrm>
-          <a:prstGeom prst="rect">
-            <a:avLst/>
-          </a:prstGeom>
-          <a:noFill/>
-        </p:spPr>
-        <p:txBody>
-          <a:bodyPr wrap="square" anchor="ctr" lIns="0" rIns="0" tIns="0" bIns="0">
-            <a:spAutoFit/>
-          </a:bodyPr>
-          <a:lstStyle/>
-          <a:p>
-            <a:pPr algn="l">
-              <a:spcAft>
-                <a:spcPts val="400"/>
-              </a:spcAft>
-            </a:pPr>
-            <a:r>
-              <a:rPr sz="1800" b="1" i="0">
-                <a:solidFill>
-                  <a:srgbClr val="FFFFFF"/>
-                </a:solidFill>
-                <a:latin typeface="Calibri"/>
-              </a:rPr>
-              <a:t>Scan no pipeline</a:t>
-            </a:r>
-          </a:p>
-        </p:txBody>
-      </p:sp>
-      <p:sp>
-        <p:nvSpPr>
-          <p:cNvPr id="11" name="TextBox 10"/>
-          <p:cNvSpPr txBox="1"/>
-          <p:nvPr/>
-        </p:nvSpPr>
-        <p:spPr>
-          <a:xfrm>
-            <a:off x="4526279" y="2377440"/>
-            <a:ext cx="3063240" cy="1325880"/>
+            <a:off x="6537959" y="1645920"/>
+            <a:ext cx="3108960" cy="411480"/>
           </a:xfrm>
           <a:prstGeom prst="rect">
             <a:avLst/>
@@ -21992,185 +22314,31 @@
           <a:p>
             <a:pPr algn="l">
               <a:spcAft>
-                <a:spcPts val="500"/>
-              </a:spcAft>
-            </a:pPr>
-            <a:r>
-              <a:rPr sz="1600" b="0" i="0">
-                <a:solidFill>
-                  <a:srgbClr val="A9BCD0"/>
-                </a:solidFill>
-                <a:latin typeface="Calibri"/>
-              </a:rPr>
-              <a:t>hadolint + trivy image</a:t>
-            </a:r>
-          </a:p>
-          <a:p>
-            <a:pPr algn="l">
-              <a:spcAft>
-                <a:spcPts val="500"/>
-              </a:spcAft>
-            </a:pPr>
-            <a:r>
-              <a:rPr sz="1600" b="0" i="0">
-                <a:solidFill>
-                  <a:srgbClr val="A9BCD0"/>
-                </a:solidFill>
-                <a:latin typeface="Calibri"/>
-              </a:rPr>
-              <a:t>--exit-code 1 em CRITICAL</a:t>
-            </a:r>
-          </a:p>
-        </p:txBody>
-      </p:sp>
-      <p:sp>
-        <p:nvSpPr>
-          <p:cNvPr id="12" name="Rounded Rectangle 11"/>
-          <p:cNvSpPr/>
-          <p:nvPr/>
-        </p:nvSpPr>
-        <p:spPr>
-          <a:xfrm>
-            <a:off x="8046719" y="1645920"/>
-            <a:ext cx="3520440" cy="2194560"/>
-          </a:xfrm>
-          <a:prstGeom prst="roundRect">
-            <a:avLst>
-              <a:gd name="adj" fmla="val 8000"/>
-            </a:avLst>
-          </a:prstGeom>
-          <a:solidFill>
-            <a:srgbClr val="13314A"/>
-          </a:solidFill>
-          <a:ln>
-            <a:noFill/>
-          </a:ln>
-          <a:effectLst/>
-        </p:spPr>
-        <p:style>
-          <a:lnRef idx="1">
-            <a:schemeClr val="accent1"/>
-          </a:lnRef>
-          <a:fillRef idx="3">
-            <a:schemeClr val="accent1"/>
-          </a:fillRef>
-          <a:effectRef idx="2">
-            <a:schemeClr val="accent1"/>
-          </a:effectRef>
-          <a:fontRef idx="minor">
-            <a:schemeClr val="lt1"/>
-          </a:fontRef>
-        </p:style>
-        <p:txBody>
-          <a:bodyPr rtlCol="0" anchor="ctr"/>
-          <a:lstStyle/>
-          <a:p>
-            <a:pPr algn="ctr"/>
-          </a:p>
-        </p:txBody>
-      </p:sp>
-      <p:sp>
-        <p:nvSpPr>
-          <p:cNvPr id="13" name="Oval 12"/>
-          <p:cNvSpPr/>
-          <p:nvPr/>
-        </p:nvSpPr>
-        <p:spPr>
-          <a:xfrm>
-            <a:off x="8275319" y="1847088"/>
-            <a:ext cx="411480" cy="411480"/>
-          </a:xfrm>
-          <a:prstGeom prst="ellipse">
-            <a:avLst/>
-          </a:prstGeom>
-          <a:solidFill>
-            <a:srgbClr val="1FC8B4"/>
-          </a:solidFill>
-          <a:ln>
-            <a:noFill/>
-          </a:ln>
-          <a:effectLst/>
-        </p:spPr>
-        <p:style>
-          <a:lnRef idx="1">
-            <a:schemeClr val="accent1"/>
-          </a:lnRef>
-          <a:fillRef idx="3">
-            <a:schemeClr val="accent1"/>
-          </a:fillRef>
-          <a:effectRef idx="2">
-            <a:schemeClr val="accent1"/>
-          </a:effectRef>
-          <a:fontRef idx="minor">
-            <a:schemeClr val="lt1"/>
-          </a:fontRef>
-        </p:style>
-        <p:txBody>
-          <a:bodyPr rtlCol="0" anchor="ctr" lIns="0" rIns="0" tIns="0" bIns="0"/>
-          <a:lstStyle/>
-          <a:p>
-            <a:pPr algn="ctr"/>
-            <a:r>
-              <a:rPr sz="1400" b="1">
-                <a:solidFill>
-                  <a:srgbClr val="0B1E2D"/>
-                </a:solidFill>
-                <a:latin typeface="Calibri"/>
-              </a:rPr>
-              <a:t>3</a:t>
-            </a:r>
-          </a:p>
-        </p:txBody>
-      </p:sp>
-      <p:sp>
-        <p:nvSpPr>
-          <p:cNvPr id="14" name="TextBox 13"/>
+                <a:spcPts val="400"/>
+              </a:spcAft>
+            </a:pPr>
+            <a:r>
+              <a:rPr sz="1700" b="1" i="0">
+                <a:solidFill>
+                  <a:srgbClr val="FFFFFF"/>
+                </a:solidFill>
+                <a:latin typeface="Calibri"/>
+              </a:rPr>
+              <a:t>CVEs CRITICAL + HIGH</a:t>
+            </a:r>
+          </a:p>
+        </p:txBody>
+      </p:sp>
+      <p:sp>
+        <p:nvSpPr>
+          <p:cNvPr id="10" name="TextBox 9"/>
           <p:cNvSpPr txBox="1"/>
           <p:nvPr/>
         </p:nvSpPr>
         <p:spPr>
           <a:xfrm>
-            <a:off x="8823959" y="1847088"/>
-            <a:ext cx="2560320" cy="411480"/>
-          </a:xfrm>
-          <a:prstGeom prst="rect">
-            <a:avLst/>
-          </a:prstGeom>
-          <a:noFill/>
-        </p:spPr>
-        <p:txBody>
-          <a:bodyPr wrap="square" anchor="ctr" lIns="0" rIns="0" tIns="0" bIns="0">
-            <a:spAutoFit/>
-          </a:bodyPr>
-          <a:lstStyle/>
-          <a:p>
-            <a:pPr algn="l">
-              <a:spcAft>
-                <a:spcPts val="400"/>
-              </a:spcAft>
-            </a:pPr>
-            <a:r>
-              <a:rPr sz="1800" b="1" i="0">
-                <a:solidFill>
-                  <a:srgbClr val="FFFFFF"/>
-                </a:solidFill>
-                <a:latin typeface="Calibri"/>
-              </a:rPr>
-              <a:t>Explorar</a:t>
-            </a:r>
-          </a:p>
-        </p:txBody>
-      </p:sp>
-      <p:sp>
-        <p:nvSpPr>
-          <p:cNvPr id="15" name="TextBox 14"/>
-          <p:cNvSpPr txBox="1"/>
-          <p:nvPr/>
-        </p:nvSpPr>
-        <p:spPr>
-          <a:xfrm>
-            <a:off x="8275319" y="2377440"/>
-            <a:ext cx="3063240" cy="1325880"/>
+            <a:off x="9006840" y="1572768"/>
+            <a:ext cx="2377440" cy="548640"/>
           </a:xfrm>
           <a:prstGeom prst="rect">
             <a:avLst/>
@@ -22183,49 +22351,51 @@
           </a:bodyPr>
           <a:lstStyle/>
           <a:p>
-            <a:pPr algn="l">
-              <a:spcAft>
-                <a:spcPts val="500"/>
-              </a:spcAft>
-            </a:pPr>
-            <a:r>
-              <a:rPr sz="1600" b="0" i="0">
-                <a:solidFill>
-                  <a:srgbClr val="A9BCD0"/>
-                </a:solidFill>
-                <a:latin typeface="Calibri"/>
-              </a:rPr>
-              <a:t>Docker Scout, Chainguard, DHI</a:t>
-            </a:r>
-          </a:p>
-          <a:p>
-            <a:pPr algn="l">
-              <a:spcAft>
-                <a:spcPts val="500"/>
-              </a:spcAft>
-            </a:pPr>
-            <a:r>
-              <a:rPr sz="1600" b="0" i="0">
-                <a:solidFill>
-                  <a:srgbClr val="A9BCD0"/>
-                </a:solidFill>
-                <a:latin typeface="Calibri"/>
-              </a:rPr>
-              <a:t>Kubernetes: probes e limits</a:t>
-            </a:r>
-          </a:p>
-        </p:txBody>
-      </p:sp>
-      <p:sp>
-        <p:nvSpPr>
-          <p:cNvPr id="16" name="TextBox 15"/>
+            <a:pPr algn="r">
+              <a:spcAft>
+                <a:spcPts val="400"/>
+              </a:spcAft>
+            </a:pPr>
+            <a:r>
+              <a:rPr sz="2600" b="1" i="0">
+                <a:solidFill>
+                  <a:srgbClr val="1FC8B4"/>
+                </a:solidFill>
+                <a:latin typeface="Calibri"/>
+              </a:rPr>
+              <a:t>562 → 0</a:t>
+            </a:r>
+          </a:p>
+        </p:txBody>
+      </p:sp>
+      <p:graphicFrame>
+        <p:nvGraphicFramePr>
+          <p:cNvPr id="11" name="Chart 10"/>
+          <p:cNvGraphicFramePr>
+            <a:graphicFrameLocks noGrp="1"/>
+          </p:cNvGraphicFramePr>
+          <p:nvPr/>
+        </p:nvGraphicFramePr>
+        <p:xfrm>
+          <a:off x="6400800" y="2240280"/>
+          <a:ext cx="5074920" cy="3703320"/>
+        </p:xfrm>
+        <a:graphic>
+          <a:graphicData uri="http://schemas.openxmlformats.org/drawingml/2006/chart">
+            <c:chart xmlns:c="http://schemas.openxmlformats.org/drawingml/2006/chart" r:id="rId4"/>
+          </a:graphicData>
+        </a:graphic>
+      </p:graphicFrame>
+      <p:sp>
+        <p:nvSpPr>
+          <p:cNvPr id="12" name="TextBox 11"/>
           <p:cNvSpPr txBox="1"/>
           <p:nvPr/>
         </p:nvSpPr>
         <p:spPr>
           <a:xfrm>
-            <a:off x="548640" y="4206240"/>
-            <a:ext cx="11064240" cy="1280160"/>
+            <a:off x="548640" y="6126480"/>
+            <a:ext cx="11064240" cy="411480"/>
           </a:xfrm>
           <a:prstGeom prst="rect">
             <a:avLst/>
@@ -22240,51 +22410,26 @@
           <a:p>
             <a:pPr algn="l">
               <a:spcAft>
-                <a:spcPts val="1000"/>
-              </a:spcAft>
-            </a:pPr>
-            <a:r>
-              <a:rPr sz="1800" b="1" i="0">
+                <a:spcPts val="400"/>
+              </a:spcAft>
+            </a:pPr>
+            <a:r>
+              <a:rPr sz="1600" b="1" i="0">
                 <a:solidFill>
                   <a:srgbClr val="FFFFFF"/>
                 </a:solidFill>
                 <a:latin typeface="Calibri"/>
               </a:rPr>
-              <a:t>Repositório: </a:t>
+              <a:t>Mesma API, mesmo contrato HTTP. </a:t>
             </a:r>
             <a:r>
               <a:rPr sz="1600" b="0" i="0">
                 <a:solidFill>
                   <a:srgbClr val="A9BCD0"/>
                 </a:solidFill>
-                <a:latin typeface="Courier New"/>
-              </a:rPr>
-              <a:t>hands-on/README.md  ·  roteiro-containerizacao.md</a:t>
-            </a:r>
-          </a:p>
-          <a:p>
-            <a:pPr algn="l">
-              <a:spcAft>
-                <a:spcPts val="1000"/>
-              </a:spcAft>
-            </a:pPr>
-            <a:r>
-              <a:rPr sz="1800" b="1" i="0">
-                <a:solidFill>
-                  <a:srgbClr val="FFFFFF"/>
-                </a:solidFill>
-                <a:latin typeface="Calibri"/>
-              </a:rPr>
-              <a:t>Palestra AppSec: </a:t>
-            </a:r>
-            <a:r>
-              <a:rPr sz="1600" b="0" i="0">
-                <a:solidFill>
-                  <a:srgbClr val="A9BCD0"/>
-                </a:solidFill>
-                <a:latin typeface="Courier New"/>
-              </a:rPr>
-              <a:t>roteiro-palestra.md  (DAST, SCA, DefectDojo)</a:t>
+                <a:latin typeface="Calibri"/>
+              </a:rPr>
+              <a:t>Só mudou a forma de construir a imagem.</a:t>
             </a:r>
           </a:p>
         </p:txBody>
@@ -22298,6 +22443,762 @@
 </file>
 
 <file path=ppt/slides/slide27.xml><?xml version="1.0" encoding="utf-8"?>
+<p:sld xmlns:a="http://schemas.openxmlformats.org/drawingml/2006/main" xmlns:p="http://schemas.openxmlformats.org/presentationml/2006/main" xmlns:r="http://schemas.openxmlformats.org/officeDocument/2006/relationships">
+  <p:cSld>
+    <p:bg>
+      <p:bgPr>
+        <a:solidFill>
+          <a:srgbClr val="0B1E2D"/>
+        </a:solidFill>
+        <a:effectLst/>
+      </p:bgPr>
+    </p:bg>
+    <p:spTree>
+      <p:nvGrpSpPr>
+        <p:cNvPr id="1" name=""/>
+        <p:cNvGrpSpPr/>
+        <p:nvPr/>
+      </p:nvGrpSpPr>
+      <p:grpSpPr/>
+      <p:sp>
+        <p:nvSpPr>
+          <p:cNvPr id="2" name="TextBox 1"/>
+          <p:cNvSpPr txBox="1"/>
+          <p:nvPr/>
+        </p:nvSpPr>
+        <p:spPr>
+          <a:xfrm>
+            <a:off x="548640" y="320040"/>
+            <a:ext cx="10972800" cy="320040"/>
+          </a:xfrm>
+          <a:prstGeom prst="rect">
+            <a:avLst/>
+          </a:prstGeom>
+          <a:noFill/>
+        </p:spPr>
+        <p:txBody>
+          <a:bodyPr wrap="square" anchor="t" lIns="0" rIns="0" tIns="0" bIns="0">
+            <a:spAutoFit/>
+          </a:bodyPr>
+          <a:lstStyle/>
+          <a:p>
+            <a:pPr algn="l">
+              <a:spcAft>
+                <a:spcPts val="400"/>
+              </a:spcAft>
+            </a:pPr>
+            <a:r>
+              <a:rPr sz="1300" b="1" i="0">
+                <a:solidFill>
+                  <a:srgbClr val="2496ED"/>
+                </a:solidFill>
+                <a:latin typeface="Calibri"/>
+              </a:rPr>
+              <a:t>ENCERRAMENTO</a:t>
+            </a:r>
+          </a:p>
+        </p:txBody>
+      </p:sp>
+      <p:sp>
+        <p:nvSpPr>
+          <p:cNvPr id="3" name="TextBox 2"/>
+          <p:cNvSpPr txBox="1"/>
+          <p:nvPr/>
+        </p:nvSpPr>
+        <p:spPr>
+          <a:xfrm>
+            <a:off x="548640" y="566928"/>
+            <a:ext cx="11064240" cy="731520"/>
+          </a:xfrm>
+          <a:prstGeom prst="rect">
+            <a:avLst/>
+          </a:prstGeom>
+          <a:noFill/>
+        </p:spPr>
+        <p:txBody>
+          <a:bodyPr wrap="square" anchor="t" lIns="0" rIns="0" tIns="0" bIns="0">
+            <a:spAutoFit/>
+          </a:bodyPr>
+          <a:lstStyle/>
+          <a:p>
+            <a:pPr algn="l">
+              <a:spcAft>
+                <a:spcPts val="400"/>
+              </a:spcAft>
+            </a:pPr>
+            <a:r>
+              <a:rPr sz="3600" b="1" i="0">
+                <a:solidFill>
+                  <a:srgbClr val="FFFFFF"/>
+                </a:solidFill>
+                <a:latin typeface="Calibri"/>
+              </a:rPr>
+              <a:t>Para levar para segunda-feira</a:t>
+            </a:r>
+          </a:p>
+        </p:txBody>
+      </p:sp>
+      <p:sp>
+        <p:nvSpPr>
+          <p:cNvPr id="4" name="Rounded Rectangle 3"/>
+          <p:cNvSpPr/>
+          <p:nvPr/>
+        </p:nvSpPr>
+        <p:spPr>
+          <a:xfrm>
+            <a:off x="548640" y="1645920"/>
+            <a:ext cx="3520440" cy="2194560"/>
+          </a:xfrm>
+          <a:prstGeom prst="roundRect">
+            <a:avLst>
+              <a:gd name="adj" fmla="val 8000"/>
+            </a:avLst>
+          </a:prstGeom>
+          <a:solidFill>
+            <a:srgbClr val="13314A"/>
+          </a:solidFill>
+          <a:ln>
+            <a:noFill/>
+          </a:ln>
+          <a:effectLst/>
+        </p:spPr>
+        <p:style>
+          <a:lnRef idx="1">
+            <a:schemeClr val="accent1"/>
+          </a:lnRef>
+          <a:fillRef idx="3">
+            <a:schemeClr val="accent1"/>
+          </a:fillRef>
+          <a:effectRef idx="2">
+            <a:schemeClr val="accent1"/>
+          </a:effectRef>
+          <a:fontRef idx="minor">
+            <a:schemeClr val="lt1"/>
+          </a:fontRef>
+        </p:style>
+        <p:txBody>
+          <a:bodyPr rtlCol="0" anchor="ctr"/>
+          <a:lstStyle/>
+          <a:p>
+            <a:pPr algn="ctr"/>
+          </a:p>
+        </p:txBody>
+      </p:sp>
+      <p:sp>
+        <p:nvSpPr>
+          <p:cNvPr id="5" name="Oval 4"/>
+          <p:cNvSpPr/>
+          <p:nvPr/>
+        </p:nvSpPr>
+        <p:spPr>
+          <a:xfrm>
+            <a:off x="777240" y="1847088"/>
+            <a:ext cx="411480" cy="411480"/>
+          </a:xfrm>
+          <a:prstGeom prst="ellipse">
+            <a:avLst/>
+          </a:prstGeom>
+          <a:solidFill>
+            <a:srgbClr val="2496ED"/>
+          </a:solidFill>
+          <a:ln>
+            <a:noFill/>
+          </a:ln>
+          <a:effectLst/>
+        </p:spPr>
+        <p:style>
+          <a:lnRef idx="1">
+            <a:schemeClr val="accent1"/>
+          </a:lnRef>
+          <a:fillRef idx="3">
+            <a:schemeClr val="accent1"/>
+          </a:fillRef>
+          <a:effectRef idx="2">
+            <a:schemeClr val="accent1"/>
+          </a:effectRef>
+          <a:fontRef idx="minor">
+            <a:schemeClr val="lt1"/>
+          </a:fontRef>
+        </p:style>
+        <p:txBody>
+          <a:bodyPr rtlCol="0" anchor="ctr" lIns="0" rIns="0" tIns="0" bIns="0"/>
+          <a:lstStyle/>
+          <a:p>
+            <a:pPr algn="ctr"/>
+            <a:r>
+              <a:rPr sz="1400" b="1">
+                <a:solidFill>
+                  <a:srgbClr val="0B1E2D"/>
+                </a:solidFill>
+                <a:latin typeface="Calibri"/>
+              </a:rPr>
+              <a:t>1</a:t>
+            </a:r>
+          </a:p>
+        </p:txBody>
+      </p:sp>
+      <p:sp>
+        <p:nvSpPr>
+          <p:cNvPr id="6" name="TextBox 5"/>
+          <p:cNvSpPr txBox="1"/>
+          <p:nvPr/>
+        </p:nvSpPr>
+        <p:spPr>
+          <a:xfrm>
+            <a:off x="1325880" y="1847088"/>
+            <a:ext cx="2560320" cy="411480"/>
+          </a:xfrm>
+          <a:prstGeom prst="rect">
+            <a:avLst/>
+          </a:prstGeom>
+          <a:noFill/>
+        </p:spPr>
+        <p:txBody>
+          <a:bodyPr wrap="square" anchor="ctr" lIns="0" rIns="0" tIns="0" bIns="0">
+            <a:spAutoFit/>
+          </a:bodyPr>
+          <a:lstStyle/>
+          <a:p>
+            <a:pPr algn="l">
+              <a:spcAft>
+                <a:spcPts val="400"/>
+              </a:spcAft>
+            </a:pPr>
+            <a:r>
+              <a:rPr sz="1800" b="1" i="0">
+                <a:solidFill>
+                  <a:srgbClr val="FFFFFF"/>
+                </a:solidFill>
+                <a:latin typeface="Calibri"/>
+              </a:rPr>
+              <a:t>Aplicar o checklist</a:t>
+            </a:r>
+          </a:p>
+        </p:txBody>
+      </p:sp>
+      <p:sp>
+        <p:nvSpPr>
+          <p:cNvPr id="7" name="TextBox 6"/>
+          <p:cNvSpPr txBox="1"/>
+          <p:nvPr/>
+        </p:nvSpPr>
+        <p:spPr>
+          <a:xfrm>
+            <a:off x="777240" y="2377440"/>
+            <a:ext cx="3063240" cy="1325880"/>
+          </a:xfrm>
+          <a:prstGeom prst="rect">
+            <a:avLst/>
+          </a:prstGeom>
+          <a:noFill/>
+        </p:spPr>
+        <p:txBody>
+          <a:bodyPr wrap="square" anchor="t" lIns="0" rIns="0" tIns="0" bIns="0">
+            <a:spAutoFit/>
+          </a:bodyPr>
+          <a:lstStyle/>
+          <a:p>
+            <a:pPr algn="l">
+              <a:spcAft>
+                <a:spcPts val="500"/>
+              </a:spcAft>
+            </a:pPr>
+            <a:r>
+              <a:rPr sz="1600" b="0" i="0">
+                <a:solidFill>
+                  <a:srgbClr val="A9BCD0"/>
+                </a:solidFill>
+                <a:latin typeface="Calibri"/>
+              </a:rPr>
+              <a:t>nos Dockerfiles do time</a:t>
+            </a:r>
+          </a:p>
+          <a:p>
+            <a:pPr algn="l">
+              <a:spcAft>
+                <a:spcPts val="500"/>
+              </a:spcAft>
+            </a:pPr>
+            <a:r>
+              <a:rPr sz="1600" b="0" i="0">
+                <a:solidFill>
+                  <a:srgbClr val="A9BCD0"/>
+                </a:solidFill>
+                <a:latin typeface="Calibri"/>
+              </a:rPr>
+              <a:t>comece pelo multi-stage</a:t>
+            </a:r>
+          </a:p>
+        </p:txBody>
+      </p:sp>
+      <p:sp>
+        <p:nvSpPr>
+          <p:cNvPr id="8" name="Rounded Rectangle 7"/>
+          <p:cNvSpPr/>
+          <p:nvPr/>
+        </p:nvSpPr>
+        <p:spPr>
+          <a:xfrm>
+            <a:off x="4297679" y="1645920"/>
+            <a:ext cx="3520440" cy="2194560"/>
+          </a:xfrm>
+          <a:prstGeom prst="roundRect">
+            <a:avLst>
+              <a:gd name="adj" fmla="val 8000"/>
+            </a:avLst>
+          </a:prstGeom>
+          <a:solidFill>
+            <a:srgbClr val="13314A"/>
+          </a:solidFill>
+          <a:ln>
+            <a:noFill/>
+          </a:ln>
+          <a:effectLst/>
+        </p:spPr>
+        <p:style>
+          <a:lnRef idx="1">
+            <a:schemeClr val="accent1"/>
+          </a:lnRef>
+          <a:fillRef idx="3">
+            <a:schemeClr val="accent1"/>
+          </a:fillRef>
+          <a:effectRef idx="2">
+            <a:schemeClr val="accent1"/>
+          </a:effectRef>
+          <a:fontRef idx="minor">
+            <a:schemeClr val="lt1"/>
+          </a:fontRef>
+        </p:style>
+        <p:txBody>
+          <a:bodyPr rtlCol="0" anchor="ctr"/>
+          <a:lstStyle/>
+          <a:p>
+            <a:pPr algn="ctr"/>
+          </a:p>
+        </p:txBody>
+      </p:sp>
+      <p:sp>
+        <p:nvSpPr>
+          <p:cNvPr id="9" name="Oval 8"/>
+          <p:cNvSpPr/>
+          <p:nvPr/>
+        </p:nvSpPr>
+        <p:spPr>
+          <a:xfrm>
+            <a:off x="4526279" y="1847088"/>
+            <a:ext cx="411480" cy="411480"/>
+          </a:xfrm>
+          <a:prstGeom prst="ellipse">
+            <a:avLst/>
+          </a:prstGeom>
+          <a:solidFill>
+            <a:srgbClr val="FFB020"/>
+          </a:solidFill>
+          <a:ln>
+            <a:noFill/>
+          </a:ln>
+          <a:effectLst/>
+        </p:spPr>
+        <p:style>
+          <a:lnRef idx="1">
+            <a:schemeClr val="accent1"/>
+          </a:lnRef>
+          <a:fillRef idx="3">
+            <a:schemeClr val="accent1"/>
+          </a:fillRef>
+          <a:effectRef idx="2">
+            <a:schemeClr val="accent1"/>
+          </a:effectRef>
+          <a:fontRef idx="minor">
+            <a:schemeClr val="lt1"/>
+          </a:fontRef>
+        </p:style>
+        <p:txBody>
+          <a:bodyPr rtlCol="0" anchor="ctr" lIns="0" rIns="0" tIns="0" bIns="0"/>
+          <a:lstStyle/>
+          <a:p>
+            <a:pPr algn="ctr"/>
+            <a:r>
+              <a:rPr sz="1400" b="1">
+                <a:solidFill>
+                  <a:srgbClr val="0B1E2D"/>
+                </a:solidFill>
+                <a:latin typeface="Calibri"/>
+              </a:rPr>
+              <a:t>2</a:t>
+            </a:r>
+          </a:p>
+        </p:txBody>
+      </p:sp>
+      <p:sp>
+        <p:nvSpPr>
+          <p:cNvPr id="10" name="TextBox 9"/>
+          <p:cNvSpPr txBox="1"/>
+          <p:nvPr/>
+        </p:nvSpPr>
+        <p:spPr>
+          <a:xfrm>
+            <a:off x="5074919" y="1847088"/>
+            <a:ext cx="2560320" cy="411480"/>
+          </a:xfrm>
+          <a:prstGeom prst="rect">
+            <a:avLst/>
+          </a:prstGeom>
+          <a:noFill/>
+        </p:spPr>
+        <p:txBody>
+          <a:bodyPr wrap="square" anchor="ctr" lIns="0" rIns="0" tIns="0" bIns="0">
+            <a:spAutoFit/>
+          </a:bodyPr>
+          <a:lstStyle/>
+          <a:p>
+            <a:pPr algn="l">
+              <a:spcAft>
+                <a:spcPts val="400"/>
+              </a:spcAft>
+            </a:pPr>
+            <a:r>
+              <a:rPr sz="1800" b="1" i="0">
+                <a:solidFill>
+                  <a:srgbClr val="FFFFFF"/>
+                </a:solidFill>
+                <a:latin typeface="Calibri"/>
+              </a:rPr>
+              <a:t>Scan no pipeline</a:t>
+            </a:r>
+          </a:p>
+        </p:txBody>
+      </p:sp>
+      <p:sp>
+        <p:nvSpPr>
+          <p:cNvPr id="11" name="TextBox 10"/>
+          <p:cNvSpPr txBox="1"/>
+          <p:nvPr/>
+        </p:nvSpPr>
+        <p:spPr>
+          <a:xfrm>
+            <a:off x="4526279" y="2377440"/>
+            <a:ext cx="3063240" cy="1325880"/>
+          </a:xfrm>
+          <a:prstGeom prst="rect">
+            <a:avLst/>
+          </a:prstGeom>
+          <a:noFill/>
+        </p:spPr>
+        <p:txBody>
+          <a:bodyPr wrap="square" anchor="t" lIns="0" rIns="0" tIns="0" bIns="0">
+            <a:spAutoFit/>
+          </a:bodyPr>
+          <a:lstStyle/>
+          <a:p>
+            <a:pPr algn="l">
+              <a:spcAft>
+                <a:spcPts val="500"/>
+              </a:spcAft>
+            </a:pPr>
+            <a:r>
+              <a:rPr sz="1600" b="0" i="0">
+                <a:solidFill>
+                  <a:srgbClr val="A9BCD0"/>
+                </a:solidFill>
+                <a:latin typeface="Calibri"/>
+              </a:rPr>
+              <a:t>hadolint + trivy image</a:t>
+            </a:r>
+          </a:p>
+          <a:p>
+            <a:pPr algn="l">
+              <a:spcAft>
+                <a:spcPts val="500"/>
+              </a:spcAft>
+            </a:pPr>
+            <a:r>
+              <a:rPr sz="1600" b="0" i="0">
+                <a:solidFill>
+                  <a:srgbClr val="A9BCD0"/>
+                </a:solidFill>
+                <a:latin typeface="Calibri"/>
+              </a:rPr>
+              <a:t>--exit-code 1 em CRITICAL</a:t>
+            </a:r>
+          </a:p>
+        </p:txBody>
+      </p:sp>
+      <p:sp>
+        <p:nvSpPr>
+          <p:cNvPr id="12" name="Rounded Rectangle 11"/>
+          <p:cNvSpPr/>
+          <p:nvPr/>
+        </p:nvSpPr>
+        <p:spPr>
+          <a:xfrm>
+            <a:off x="8046719" y="1645920"/>
+            <a:ext cx="3520440" cy="2194560"/>
+          </a:xfrm>
+          <a:prstGeom prst="roundRect">
+            <a:avLst>
+              <a:gd name="adj" fmla="val 8000"/>
+            </a:avLst>
+          </a:prstGeom>
+          <a:solidFill>
+            <a:srgbClr val="13314A"/>
+          </a:solidFill>
+          <a:ln>
+            <a:noFill/>
+          </a:ln>
+          <a:effectLst/>
+        </p:spPr>
+        <p:style>
+          <a:lnRef idx="1">
+            <a:schemeClr val="accent1"/>
+          </a:lnRef>
+          <a:fillRef idx="3">
+            <a:schemeClr val="accent1"/>
+          </a:fillRef>
+          <a:effectRef idx="2">
+            <a:schemeClr val="accent1"/>
+          </a:effectRef>
+          <a:fontRef idx="minor">
+            <a:schemeClr val="lt1"/>
+          </a:fontRef>
+        </p:style>
+        <p:txBody>
+          <a:bodyPr rtlCol="0" anchor="ctr"/>
+          <a:lstStyle/>
+          <a:p>
+            <a:pPr algn="ctr"/>
+          </a:p>
+        </p:txBody>
+      </p:sp>
+      <p:sp>
+        <p:nvSpPr>
+          <p:cNvPr id="13" name="Oval 12"/>
+          <p:cNvSpPr/>
+          <p:nvPr/>
+        </p:nvSpPr>
+        <p:spPr>
+          <a:xfrm>
+            <a:off x="8275319" y="1847088"/>
+            <a:ext cx="411480" cy="411480"/>
+          </a:xfrm>
+          <a:prstGeom prst="ellipse">
+            <a:avLst/>
+          </a:prstGeom>
+          <a:solidFill>
+            <a:srgbClr val="1FC8B4"/>
+          </a:solidFill>
+          <a:ln>
+            <a:noFill/>
+          </a:ln>
+          <a:effectLst/>
+        </p:spPr>
+        <p:style>
+          <a:lnRef idx="1">
+            <a:schemeClr val="accent1"/>
+          </a:lnRef>
+          <a:fillRef idx="3">
+            <a:schemeClr val="accent1"/>
+          </a:fillRef>
+          <a:effectRef idx="2">
+            <a:schemeClr val="accent1"/>
+          </a:effectRef>
+          <a:fontRef idx="minor">
+            <a:schemeClr val="lt1"/>
+          </a:fontRef>
+        </p:style>
+        <p:txBody>
+          <a:bodyPr rtlCol="0" anchor="ctr" lIns="0" rIns="0" tIns="0" bIns="0"/>
+          <a:lstStyle/>
+          <a:p>
+            <a:pPr algn="ctr"/>
+            <a:r>
+              <a:rPr sz="1400" b="1">
+                <a:solidFill>
+                  <a:srgbClr val="0B1E2D"/>
+                </a:solidFill>
+                <a:latin typeface="Calibri"/>
+              </a:rPr>
+              <a:t>3</a:t>
+            </a:r>
+          </a:p>
+        </p:txBody>
+      </p:sp>
+      <p:sp>
+        <p:nvSpPr>
+          <p:cNvPr id="14" name="TextBox 13"/>
+          <p:cNvSpPr txBox="1"/>
+          <p:nvPr/>
+        </p:nvSpPr>
+        <p:spPr>
+          <a:xfrm>
+            <a:off x="8823959" y="1847088"/>
+            <a:ext cx="2560320" cy="411480"/>
+          </a:xfrm>
+          <a:prstGeom prst="rect">
+            <a:avLst/>
+          </a:prstGeom>
+          <a:noFill/>
+        </p:spPr>
+        <p:txBody>
+          <a:bodyPr wrap="square" anchor="ctr" lIns="0" rIns="0" tIns="0" bIns="0">
+            <a:spAutoFit/>
+          </a:bodyPr>
+          <a:lstStyle/>
+          <a:p>
+            <a:pPr algn="l">
+              <a:spcAft>
+                <a:spcPts val="400"/>
+              </a:spcAft>
+            </a:pPr>
+            <a:r>
+              <a:rPr sz="1800" b="1" i="0">
+                <a:solidFill>
+                  <a:srgbClr val="FFFFFF"/>
+                </a:solidFill>
+                <a:latin typeface="Calibri"/>
+              </a:rPr>
+              <a:t>Explorar</a:t>
+            </a:r>
+          </a:p>
+        </p:txBody>
+      </p:sp>
+      <p:sp>
+        <p:nvSpPr>
+          <p:cNvPr id="15" name="TextBox 14"/>
+          <p:cNvSpPr txBox="1"/>
+          <p:nvPr/>
+        </p:nvSpPr>
+        <p:spPr>
+          <a:xfrm>
+            <a:off x="8275319" y="2377440"/>
+            <a:ext cx="3063240" cy="1325880"/>
+          </a:xfrm>
+          <a:prstGeom prst="rect">
+            <a:avLst/>
+          </a:prstGeom>
+          <a:noFill/>
+        </p:spPr>
+        <p:txBody>
+          <a:bodyPr wrap="square" anchor="t" lIns="0" rIns="0" tIns="0" bIns="0">
+            <a:spAutoFit/>
+          </a:bodyPr>
+          <a:lstStyle/>
+          <a:p>
+            <a:pPr algn="l">
+              <a:spcAft>
+                <a:spcPts val="500"/>
+              </a:spcAft>
+            </a:pPr>
+            <a:r>
+              <a:rPr sz="1600" b="0" i="0">
+                <a:solidFill>
+                  <a:srgbClr val="A9BCD0"/>
+                </a:solidFill>
+                <a:latin typeface="Calibri"/>
+              </a:rPr>
+              <a:t>Docker Scout, Chainguard, DHI</a:t>
+            </a:r>
+          </a:p>
+          <a:p>
+            <a:pPr algn="l">
+              <a:spcAft>
+                <a:spcPts val="500"/>
+              </a:spcAft>
+            </a:pPr>
+            <a:r>
+              <a:rPr sz="1600" b="0" i="0">
+                <a:solidFill>
+                  <a:srgbClr val="A9BCD0"/>
+                </a:solidFill>
+                <a:latin typeface="Calibri"/>
+              </a:rPr>
+              <a:t>Kubernetes: probes e limits</a:t>
+            </a:r>
+          </a:p>
+        </p:txBody>
+      </p:sp>
+      <p:sp>
+        <p:nvSpPr>
+          <p:cNvPr id="16" name="TextBox 15"/>
+          <p:cNvSpPr txBox="1"/>
+          <p:nvPr/>
+        </p:nvSpPr>
+        <p:spPr>
+          <a:xfrm>
+            <a:off x="548640" y="4206240"/>
+            <a:ext cx="11064240" cy="1280160"/>
+          </a:xfrm>
+          <a:prstGeom prst="rect">
+            <a:avLst/>
+          </a:prstGeom>
+          <a:noFill/>
+        </p:spPr>
+        <p:txBody>
+          <a:bodyPr wrap="square" anchor="t" lIns="0" rIns="0" tIns="0" bIns="0">
+            <a:spAutoFit/>
+          </a:bodyPr>
+          <a:lstStyle/>
+          <a:p>
+            <a:pPr algn="l">
+              <a:spcAft>
+                <a:spcPts val="1000"/>
+              </a:spcAft>
+            </a:pPr>
+            <a:r>
+              <a:rPr sz="1800" b="1" i="0">
+                <a:solidFill>
+                  <a:srgbClr val="FFFFFF"/>
+                </a:solidFill>
+                <a:latin typeface="Calibri"/>
+              </a:rPr>
+              <a:t>Repositório: </a:t>
+            </a:r>
+            <a:r>
+              <a:rPr sz="1600" b="0" i="0">
+                <a:solidFill>
+                  <a:srgbClr val="A9BCD0"/>
+                </a:solidFill>
+                <a:latin typeface="Courier New"/>
+              </a:rPr>
+              <a:t>hands-on/README.md  ·  roteiro-containerizacao.md</a:t>
+            </a:r>
+          </a:p>
+          <a:p>
+            <a:pPr algn="l">
+              <a:spcAft>
+                <a:spcPts val="1000"/>
+              </a:spcAft>
+            </a:pPr>
+            <a:r>
+              <a:rPr sz="1800" b="1" i="0">
+                <a:solidFill>
+                  <a:srgbClr val="FFFFFF"/>
+                </a:solidFill>
+                <a:latin typeface="Calibri"/>
+              </a:rPr>
+              <a:t>Palestra AppSec: </a:t>
+            </a:r>
+            <a:r>
+              <a:rPr sz="1600" b="0" i="0">
+                <a:solidFill>
+                  <a:srgbClr val="A9BCD0"/>
+                </a:solidFill>
+                <a:latin typeface="Courier New"/>
+              </a:rPr>
+              <a:t>roteiro-palestra.md  (DAST, SCA, DefectDojo)</a:t>
+            </a:r>
+          </a:p>
+        </p:txBody>
+      </p:sp>
+    </p:spTree>
+  </p:cSld>
+  <p:clrMapOvr>
+    <a:masterClrMapping/>
+  </p:clrMapOvr>
+</p:sld>
+</file>
+
+<file path=ppt/slides/slide28.xml><?xml version="1.0" encoding="utf-8"?>
 <p:sld xmlns:a="http://schemas.openxmlformats.org/drawingml/2006/main" xmlns:p="http://schemas.openxmlformats.org/presentationml/2006/main" xmlns:r="http://schemas.openxmlformats.org/officeDocument/2006/relationships">
   <p:cSld>
     <p:bg>

</xml_diff>